<commit_message>
Question Taeke Stavenga on 3D flow added.
</commit_message>
<xml_diff>
--- a/Projects/ARK_RWS/images/Plaatjes_RWS_ARK.pptx
+++ b/Projects/ARK_RWS/images/Plaatjes_RWS_ARK.pptx
@@ -5,7 +5,7 @@
     <p:sldMasterId id="2147483660" r:id="rId1"/>
   </p:sldMasterIdLst>
   <p:notesMasterIdLst>
-    <p:notesMasterId r:id="rId9"/>
+    <p:notesMasterId r:id="rId10"/>
   </p:notesMasterIdLst>
   <p:sldIdLst>
     <p:sldId id="256" r:id="rId2"/>
@@ -15,6 +15,7 @@
     <p:sldId id="260" r:id="rId6"/>
     <p:sldId id="261" r:id="rId7"/>
     <p:sldId id="262" r:id="rId8"/>
+    <p:sldId id="263" r:id="rId9"/>
   </p:sldIdLst>
   <p:sldSz cx="9144000" cy="6858000" type="screen4x3"/>
   <p:notesSz cx="6858000" cy="9144000"/>
@@ -214,7 +215,7 @@
           <a:p>
             <a:fld id="{2088E2FE-21FC-6D40-83CF-D5B3B52CADA7}" type="datetimeFigureOut">
               <a:rPr lang="en-US" smtClean="0"/>
-              <a:t>4/26/26</a:t>
+              <a:t>6/12/26</a:t>
             </a:fld>
             <a:endParaRPr lang="en-US"/>
           </a:p>
@@ -1128,7 +1129,7 @@
           <a:p>
             <a:fld id="{A6AF225C-868F-9540-9455-9F5B5C0F2A40}" type="datetimeFigureOut">
               <a:rPr lang="en-US" smtClean="0"/>
-              <a:t>4/26/26</a:t>
+              <a:t>6/12/26</a:t>
             </a:fld>
             <a:endParaRPr lang="en-US"/>
           </a:p>
@@ -1298,7 +1299,7 @@
           <a:p>
             <a:fld id="{A6AF225C-868F-9540-9455-9F5B5C0F2A40}" type="datetimeFigureOut">
               <a:rPr lang="en-US" smtClean="0"/>
-              <a:t>4/26/26</a:t>
+              <a:t>6/12/26</a:t>
             </a:fld>
             <a:endParaRPr lang="en-US"/>
           </a:p>
@@ -1478,7 +1479,7 @@
           <a:p>
             <a:fld id="{A6AF225C-868F-9540-9455-9F5B5C0F2A40}" type="datetimeFigureOut">
               <a:rPr lang="en-US" smtClean="0"/>
-              <a:t>4/26/26</a:t>
+              <a:t>6/12/26</a:t>
             </a:fld>
             <a:endParaRPr lang="en-US"/>
           </a:p>
@@ -1648,7 +1649,7 @@
           <a:p>
             <a:fld id="{A6AF225C-868F-9540-9455-9F5B5C0F2A40}" type="datetimeFigureOut">
               <a:rPr lang="en-US" smtClean="0"/>
-              <a:t>4/26/26</a:t>
+              <a:t>6/12/26</a:t>
             </a:fld>
             <a:endParaRPr lang="en-US"/>
           </a:p>
@@ -1894,7 +1895,7 @@
           <a:p>
             <a:fld id="{A6AF225C-868F-9540-9455-9F5B5C0F2A40}" type="datetimeFigureOut">
               <a:rPr lang="en-US" smtClean="0"/>
-              <a:t>4/26/26</a:t>
+              <a:t>6/12/26</a:t>
             </a:fld>
             <a:endParaRPr lang="en-US"/>
           </a:p>
@@ -2126,7 +2127,7 @@
           <a:p>
             <a:fld id="{A6AF225C-868F-9540-9455-9F5B5C0F2A40}" type="datetimeFigureOut">
               <a:rPr lang="en-US" smtClean="0"/>
-              <a:t>4/26/26</a:t>
+              <a:t>6/12/26</a:t>
             </a:fld>
             <a:endParaRPr lang="en-US"/>
           </a:p>
@@ -2493,7 +2494,7 @@
           <a:p>
             <a:fld id="{A6AF225C-868F-9540-9455-9F5B5C0F2A40}" type="datetimeFigureOut">
               <a:rPr lang="en-US" smtClean="0"/>
-              <a:t>4/26/26</a:t>
+              <a:t>6/12/26</a:t>
             </a:fld>
             <a:endParaRPr lang="en-US"/>
           </a:p>
@@ -2611,7 +2612,7 @@
           <a:p>
             <a:fld id="{A6AF225C-868F-9540-9455-9F5B5C0F2A40}" type="datetimeFigureOut">
               <a:rPr lang="en-US" smtClean="0"/>
-              <a:t>4/26/26</a:t>
+              <a:t>6/12/26</a:t>
             </a:fld>
             <a:endParaRPr lang="en-US"/>
           </a:p>
@@ -2706,7 +2707,7 @@
           <a:p>
             <a:fld id="{A6AF225C-868F-9540-9455-9F5B5C0F2A40}" type="datetimeFigureOut">
               <a:rPr lang="en-US" smtClean="0"/>
-              <a:t>4/26/26</a:t>
+              <a:t>6/12/26</a:t>
             </a:fld>
             <a:endParaRPr lang="en-US"/>
           </a:p>
@@ -2983,7 +2984,7 @@
           <a:p>
             <a:fld id="{A6AF225C-868F-9540-9455-9F5B5C0F2A40}" type="datetimeFigureOut">
               <a:rPr lang="en-US" smtClean="0"/>
-              <a:t>4/26/26</a:t>
+              <a:t>6/12/26</a:t>
             </a:fld>
             <a:endParaRPr lang="en-US"/>
           </a:p>
@@ -3240,7 +3241,7 @@
           <a:p>
             <a:fld id="{A6AF225C-868F-9540-9455-9F5B5C0F2A40}" type="datetimeFigureOut">
               <a:rPr lang="en-US" smtClean="0"/>
-              <a:t>4/26/26</a:t>
+              <a:t>6/12/26</a:t>
             </a:fld>
             <a:endParaRPr lang="en-US"/>
           </a:p>
@@ -3453,7 +3454,7 @@
           <a:p>
             <a:fld id="{A6AF225C-868F-9540-9455-9F5B5C0F2A40}" type="datetimeFigureOut">
               <a:rPr lang="en-US" smtClean="0"/>
-              <a:t>4/26/26</a:t>
+              <a:t>6/12/26</a:t>
             </a:fld>
             <a:endParaRPr lang="en-US"/>
           </a:p>
@@ -13576,6 +13577,877 @@
     <p:extLst>
       <p:ext uri="{BB962C8B-B14F-4D97-AF65-F5344CB8AC3E}">
         <p14:creationId xmlns:p14="http://schemas.microsoft.com/office/powerpoint/2010/main" val="2123514046"/>
+      </p:ext>
+    </p:extLst>
+  </p:cSld>
+  <p:clrMapOvr>
+    <a:masterClrMapping/>
+  </p:clrMapOvr>
+</p:sld>
+</file>
+
+<file path=ppt/slides/slide8.xml><?xml version="1.0" encoding="utf-8"?>
+<p:sld xmlns:a="http://schemas.openxmlformats.org/drawingml/2006/main" xmlns:r="http://schemas.openxmlformats.org/officeDocument/2006/relationships" xmlns:p="http://schemas.openxmlformats.org/presentationml/2006/main">
+  <p:cSld>
+    <p:spTree>
+      <p:nvGrpSpPr>
+        <p:cNvPr id="1" name=""/>
+        <p:cNvGrpSpPr/>
+        <p:nvPr/>
+      </p:nvGrpSpPr>
+      <p:grpSpPr>
+        <a:xfrm>
+          <a:off x="0" y="0"/>
+          <a:ext cx="0" cy="0"/>
+          <a:chOff x="0" y="0"/>
+          <a:chExt cx="0" cy="0"/>
+        </a:xfrm>
+      </p:grpSpPr>
+      <p:grpSp>
+        <p:nvGrpSpPr>
+          <p:cNvPr id="42" name="Group 41">
+            <a:extLst>
+              <a:ext uri="{FF2B5EF4-FFF2-40B4-BE49-F238E27FC236}">
+                <a16:creationId xmlns:a16="http://schemas.microsoft.com/office/drawing/2014/main" id="{A8319626-4FCB-503E-9C6A-5FE36B58081C}"/>
+              </a:ext>
+            </a:extLst>
+          </p:cNvPr>
+          <p:cNvGrpSpPr/>
+          <p:nvPr/>
+        </p:nvGrpSpPr>
+        <p:grpSpPr>
+          <a:xfrm>
+            <a:off x="1410182" y="460978"/>
+            <a:ext cx="5538805" cy="3852589"/>
+            <a:chOff x="1410182" y="460978"/>
+            <a:chExt cx="5538805" cy="3852589"/>
+          </a:xfrm>
+        </p:grpSpPr>
+        <p:cxnSp>
+          <p:nvCxnSpPr>
+            <p:cNvPr id="3" name="Straight Connector 2">
+              <a:extLst>
+                <a:ext uri="{FF2B5EF4-FFF2-40B4-BE49-F238E27FC236}">
+                  <a16:creationId xmlns:a16="http://schemas.microsoft.com/office/drawing/2014/main" id="{A5210F3F-9B1E-FE2D-FE21-A1A8443A15B4}"/>
+                </a:ext>
+              </a:extLst>
+            </p:cNvPr>
+            <p:cNvCxnSpPr>
+              <a:cxnSpLocks/>
+            </p:cNvCxnSpPr>
+            <p:nvPr/>
+          </p:nvCxnSpPr>
+          <p:spPr>
+            <a:xfrm>
+              <a:off x="3253563" y="1403498"/>
+              <a:ext cx="0" cy="1020725"/>
+            </a:xfrm>
+            <a:prstGeom prst="line">
+              <a:avLst/>
+            </a:prstGeom>
+            <a:ln>
+              <a:tailEnd type="triangle" w="lg" len="lg"/>
+            </a:ln>
+          </p:spPr>
+          <p:style>
+            <a:lnRef idx="2">
+              <a:schemeClr val="accent1"/>
+            </a:lnRef>
+            <a:fillRef idx="0">
+              <a:schemeClr val="accent1"/>
+            </a:fillRef>
+            <a:effectRef idx="1">
+              <a:schemeClr val="accent1"/>
+            </a:effectRef>
+            <a:fontRef idx="minor">
+              <a:schemeClr val="tx1"/>
+            </a:fontRef>
+          </p:style>
+        </p:cxnSp>
+        <p:pic>
+          <p:nvPicPr>
+            <p:cNvPr id="6" name="Picture 5">
+              <a:extLst>
+                <a:ext uri="{FF2B5EF4-FFF2-40B4-BE49-F238E27FC236}">
+                  <a16:creationId xmlns:a16="http://schemas.microsoft.com/office/drawing/2014/main" id="{37AD9660-6959-F528-243D-4BA43EFE633F}"/>
+                </a:ext>
+              </a:extLst>
+            </p:cNvPr>
+            <p:cNvPicPr>
+              <a:picLocks noChangeAspect="1"/>
+            </p:cNvPicPr>
+            <p:nvPr/>
+          </p:nvPicPr>
+          <p:blipFill>
+            <a:blip r:embed="rId2"/>
+            <a:stretch>
+              <a:fillRect/>
+            </a:stretch>
+          </p:blipFill>
+          <p:spPr>
+            <a:xfrm>
+              <a:off x="2814823" y="1018067"/>
+              <a:ext cx="622300" cy="228600"/>
+            </a:xfrm>
+            <a:prstGeom prst="rect">
+              <a:avLst/>
+            </a:prstGeom>
+          </p:spPr>
+        </p:pic>
+        <p:pic>
+          <p:nvPicPr>
+            <p:cNvPr id="8" name="Picture 7">
+              <a:extLst>
+                <a:ext uri="{FF2B5EF4-FFF2-40B4-BE49-F238E27FC236}">
+                  <a16:creationId xmlns:a16="http://schemas.microsoft.com/office/drawing/2014/main" id="{2DD2B8C9-072D-C504-F2AC-E11465F9FBC5}"/>
+                </a:ext>
+              </a:extLst>
+            </p:cNvPr>
+            <p:cNvPicPr>
+              <a:picLocks noChangeAspect="1"/>
+            </p:cNvPicPr>
+            <p:nvPr/>
+          </p:nvPicPr>
+          <p:blipFill>
+            <a:blip r:embed="rId3"/>
+            <a:stretch>
+              <a:fillRect/>
+            </a:stretch>
+          </p:blipFill>
+          <p:spPr>
+            <a:xfrm>
+              <a:off x="3143544" y="4059567"/>
+              <a:ext cx="241300" cy="254000"/>
+            </a:xfrm>
+            <a:prstGeom prst="rect">
+              <a:avLst/>
+            </a:prstGeom>
+          </p:spPr>
+        </p:pic>
+        <p:cxnSp>
+          <p:nvCxnSpPr>
+            <p:cNvPr id="9" name="Straight Connector 8">
+              <a:extLst>
+                <a:ext uri="{FF2B5EF4-FFF2-40B4-BE49-F238E27FC236}">
+                  <a16:creationId xmlns:a16="http://schemas.microsoft.com/office/drawing/2014/main" id="{EECA1E16-15D0-B71A-FE7B-3CE06BC1E8DD}"/>
+                </a:ext>
+              </a:extLst>
+            </p:cNvPr>
+            <p:cNvCxnSpPr>
+              <a:cxnSpLocks/>
+            </p:cNvCxnSpPr>
+            <p:nvPr/>
+          </p:nvCxnSpPr>
+          <p:spPr>
+            <a:xfrm>
+              <a:off x="3253563" y="2918637"/>
+              <a:ext cx="0" cy="1020725"/>
+            </a:xfrm>
+            <a:prstGeom prst="line">
+              <a:avLst/>
+            </a:prstGeom>
+            <a:ln>
+              <a:tailEnd type="triangle" w="lg" len="lg"/>
+            </a:ln>
+          </p:spPr>
+          <p:style>
+            <a:lnRef idx="2">
+              <a:schemeClr val="accent1"/>
+            </a:lnRef>
+            <a:fillRef idx="0">
+              <a:schemeClr val="accent1"/>
+            </a:fillRef>
+            <a:effectRef idx="1">
+              <a:schemeClr val="accent1"/>
+            </a:effectRef>
+            <a:fontRef idx="minor">
+              <a:schemeClr val="tx1"/>
+            </a:fontRef>
+          </p:style>
+        </p:cxnSp>
+        <p:sp>
+          <p:nvSpPr>
+            <p:cNvPr id="10" name="Left Brace 9">
+              <a:extLst>
+                <a:ext uri="{FF2B5EF4-FFF2-40B4-BE49-F238E27FC236}">
+                  <a16:creationId xmlns:a16="http://schemas.microsoft.com/office/drawing/2014/main" id="{54D325D0-45BF-6FDF-A246-3DC82BED8F8F}"/>
+                </a:ext>
+              </a:extLst>
+            </p:cNvPr>
+            <p:cNvSpPr/>
+            <p:nvPr/>
+          </p:nvSpPr>
+          <p:spPr>
+            <a:xfrm>
+              <a:off x="2062719" y="1217425"/>
+              <a:ext cx="580750" cy="1464635"/>
+            </a:xfrm>
+            <a:prstGeom prst="leftBrace">
+              <a:avLst/>
+            </a:prstGeom>
+          </p:spPr>
+          <p:style>
+            <a:lnRef idx="2">
+              <a:schemeClr val="accent1"/>
+            </a:lnRef>
+            <a:fillRef idx="0">
+              <a:schemeClr val="accent1"/>
+            </a:fillRef>
+            <a:effectRef idx="1">
+              <a:schemeClr val="accent1"/>
+            </a:effectRef>
+            <a:fontRef idx="minor">
+              <a:schemeClr val="tx1"/>
+            </a:fontRef>
+          </p:style>
+          <p:txBody>
+            <a:bodyPr rtlCol="0" anchor="ctr"/>
+            <a:lstStyle/>
+            <a:p>
+              <a:pPr algn="ctr"/>
+              <a:endParaRPr lang="en-US"/>
+            </a:p>
+          </p:txBody>
+        </p:sp>
+        <p:sp>
+          <p:nvSpPr>
+            <p:cNvPr id="11" name="Left Brace 10">
+              <a:extLst>
+                <a:ext uri="{FF2B5EF4-FFF2-40B4-BE49-F238E27FC236}">
+                  <a16:creationId xmlns:a16="http://schemas.microsoft.com/office/drawing/2014/main" id="{3EE77622-4949-7011-3702-7C68BEEB4E83}"/>
+                </a:ext>
+              </a:extLst>
+            </p:cNvPr>
+            <p:cNvSpPr/>
+            <p:nvPr/>
+          </p:nvSpPr>
+          <p:spPr>
+            <a:xfrm>
+              <a:off x="2066260" y="2783952"/>
+              <a:ext cx="580750" cy="1275615"/>
+            </a:xfrm>
+            <a:prstGeom prst="leftBrace">
+              <a:avLst/>
+            </a:prstGeom>
+          </p:spPr>
+          <p:style>
+            <a:lnRef idx="2">
+              <a:schemeClr val="accent1"/>
+            </a:lnRef>
+            <a:fillRef idx="0">
+              <a:schemeClr val="accent1"/>
+            </a:fillRef>
+            <a:effectRef idx="1">
+              <a:schemeClr val="accent1"/>
+            </a:effectRef>
+            <a:fontRef idx="minor">
+              <a:schemeClr val="tx1"/>
+            </a:fontRef>
+          </p:style>
+          <p:txBody>
+            <a:bodyPr rtlCol="0" anchor="ctr"/>
+            <a:lstStyle/>
+            <a:p>
+              <a:pPr algn="ctr"/>
+              <a:endParaRPr lang="en-US"/>
+            </a:p>
+          </p:txBody>
+        </p:sp>
+        <p:pic>
+          <p:nvPicPr>
+            <p:cNvPr id="13" name="Picture 12">
+              <a:extLst>
+                <a:ext uri="{FF2B5EF4-FFF2-40B4-BE49-F238E27FC236}">
+                  <a16:creationId xmlns:a16="http://schemas.microsoft.com/office/drawing/2014/main" id="{D6E3EBFE-FCE9-0AEE-9CBB-61AD22112A97}"/>
+                </a:ext>
+              </a:extLst>
+            </p:cNvPr>
+            <p:cNvPicPr>
+              <a:picLocks noChangeAspect="1"/>
+            </p:cNvPicPr>
+            <p:nvPr/>
+          </p:nvPicPr>
+          <p:blipFill>
+            <a:blip r:embed="rId4"/>
+            <a:stretch>
+              <a:fillRect/>
+            </a:stretch>
+          </p:blipFill>
+          <p:spPr>
+            <a:xfrm>
+              <a:off x="1744322" y="3320901"/>
+              <a:ext cx="254000" cy="152400"/>
+            </a:xfrm>
+            <a:prstGeom prst="rect">
+              <a:avLst/>
+            </a:prstGeom>
+          </p:spPr>
+        </p:pic>
+        <p:cxnSp>
+          <p:nvCxnSpPr>
+            <p:cNvPr id="18" name="Straight Connector 17">
+              <a:extLst>
+                <a:ext uri="{FF2B5EF4-FFF2-40B4-BE49-F238E27FC236}">
+                  <a16:creationId xmlns:a16="http://schemas.microsoft.com/office/drawing/2014/main" id="{35C09E97-224A-24BD-78A1-6993C00D77FB}"/>
+                </a:ext>
+              </a:extLst>
+            </p:cNvPr>
+            <p:cNvCxnSpPr>
+              <a:cxnSpLocks/>
+            </p:cNvCxnSpPr>
+            <p:nvPr/>
+          </p:nvCxnSpPr>
+          <p:spPr>
+            <a:xfrm>
+              <a:off x="6253335" y="1393852"/>
+              <a:ext cx="0" cy="834654"/>
+            </a:xfrm>
+            <a:prstGeom prst="line">
+              <a:avLst/>
+            </a:prstGeom>
+            <a:ln>
+              <a:tailEnd type="triangle" w="lg" len="lg"/>
+            </a:ln>
+          </p:spPr>
+          <p:style>
+            <a:lnRef idx="2">
+              <a:schemeClr val="accent1"/>
+            </a:lnRef>
+            <a:fillRef idx="0">
+              <a:schemeClr val="accent1"/>
+            </a:fillRef>
+            <a:effectRef idx="1">
+              <a:schemeClr val="accent1"/>
+            </a:effectRef>
+            <a:fontRef idx="minor">
+              <a:schemeClr val="tx1"/>
+            </a:fontRef>
+          </p:style>
+        </p:cxnSp>
+        <p:pic>
+          <p:nvPicPr>
+            <p:cNvPr id="19" name="Picture 18">
+              <a:extLst>
+                <a:ext uri="{FF2B5EF4-FFF2-40B4-BE49-F238E27FC236}">
+                  <a16:creationId xmlns:a16="http://schemas.microsoft.com/office/drawing/2014/main" id="{FAC9AC2E-ECEB-6517-5F73-4BCC387B36E5}"/>
+                </a:ext>
+              </a:extLst>
+            </p:cNvPr>
+            <p:cNvPicPr>
+              <a:picLocks noChangeAspect="1"/>
+            </p:cNvPicPr>
+            <p:nvPr/>
+          </p:nvPicPr>
+          <p:blipFill>
+            <a:blip r:embed="rId2"/>
+            <a:stretch>
+              <a:fillRect/>
+            </a:stretch>
+          </p:blipFill>
+          <p:spPr>
+            <a:xfrm>
+              <a:off x="5814595" y="1008421"/>
+              <a:ext cx="622300" cy="228600"/>
+            </a:xfrm>
+            <a:prstGeom prst="rect">
+              <a:avLst/>
+            </a:prstGeom>
+          </p:spPr>
+        </p:pic>
+        <p:pic>
+          <p:nvPicPr>
+            <p:cNvPr id="21" name="Picture 20">
+              <a:extLst>
+                <a:ext uri="{FF2B5EF4-FFF2-40B4-BE49-F238E27FC236}">
+                  <a16:creationId xmlns:a16="http://schemas.microsoft.com/office/drawing/2014/main" id="{E8208DA6-195F-2140-50B8-7D581117DC6C}"/>
+                </a:ext>
+              </a:extLst>
+            </p:cNvPr>
+            <p:cNvPicPr>
+              <a:picLocks noChangeAspect="1"/>
+            </p:cNvPicPr>
+            <p:nvPr/>
+          </p:nvPicPr>
+          <p:blipFill>
+            <a:blip r:embed="rId3"/>
+            <a:stretch>
+              <a:fillRect/>
+            </a:stretch>
+          </p:blipFill>
+          <p:spPr>
+            <a:xfrm>
+              <a:off x="6143316" y="4049921"/>
+              <a:ext cx="241300" cy="254000"/>
+            </a:xfrm>
+            <a:prstGeom prst="rect">
+              <a:avLst/>
+            </a:prstGeom>
+          </p:spPr>
+        </p:pic>
+        <p:cxnSp>
+          <p:nvCxnSpPr>
+            <p:cNvPr id="22" name="Straight Connector 21">
+              <a:extLst>
+                <a:ext uri="{FF2B5EF4-FFF2-40B4-BE49-F238E27FC236}">
+                  <a16:creationId xmlns:a16="http://schemas.microsoft.com/office/drawing/2014/main" id="{B7D1F412-702C-A148-FEE9-77F3C70D88B3}"/>
+                </a:ext>
+              </a:extLst>
+            </p:cNvPr>
+            <p:cNvCxnSpPr>
+              <a:cxnSpLocks/>
+            </p:cNvCxnSpPr>
+            <p:nvPr/>
+          </p:nvCxnSpPr>
+          <p:spPr>
+            <a:xfrm>
+              <a:off x="6253335" y="2682060"/>
+              <a:ext cx="0" cy="1247656"/>
+            </a:xfrm>
+            <a:prstGeom prst="line">
+              <a:avLst/>
+            </a:prstGeom>
+            <a:ln>
+              <a:tailEnd type="triangle" w="lg" len="lg"/>
+            </a:ln>
+          </p:spPr>
+          <p:style>
+            <a:lnRef idx="2">
+              <a:schemeClr val="accent1"/>
+            </a:lnRef>
+            <a:fillRef idx="0">
+              <a:schemeClr val="accent1"/>
+            </a:fillRef>
+            <a:effectRef idx="1">
+              <a:schemeClr val="accent1"/>
+            </a:effectRef>
+            <a:fontRef idx="minor">
+              <a:schemeClr val="tx1"/>
+            </a:fontRef>
+          </p:style>
+        </p:cxnSp>
+        <p:sp>
+          <p:nvSpPr>
+            <p:cNvPr id="23" name="Left Brace 22">
+              <a:extLst>
+                <a:ext uri="{FF2B5EF4-FFF2-40B4-BE49-F238E27FC236}">
+                  <a16:creationId xmlns:a16="http://schemas.microsoft.com/office/drawing/2014/main" id="{086EA95A-07D1-7963-C614-13E302030B0B}"/>
+                </a:ext>
+              </a:extLst>
+            </p:cNvPr>
+            <p:cNvSpPr/>
+            <p:nvPr/>
+          </p:nvSpPr>
+          <p:spPr>
+            <a:xfrm>
+              <a:off x="5062491" y="1207780"/>
+              <a:ext cx="580750" cy="1020726"/>
+            </a:xfrm>
+            <a:prstGeom prst="leftBrace">
+              <a:avLst/>
+            </a:prstGeom>
+          </p:spPr>
+          <p:style>
+            <a:lnRef idx="2">
+              <a:schemeClr val="accent1"/>
+            </a:lnRef>
+            <a:fillRef idx="0">
+              <a:schemeClr val="accent1"/>
+            </a:fillRef>
+            <a:effectRef idx="1">
+              <a:schemeClr val="accent1"/>
+            </a:effectRef>
+            <a:fontRef idx="minor">
+              <a:schemeClr val="tx1"/>
+            </a:fontRef>
+          </p:style>
+          <p:txBody>
+            <a:bodyPr rtlCol="0" anchor="ctr"/>
+            <a:lstStyle/>
+            <a:p>
+              <a:pPr algn="ctr"/>
+              <a:endParaRPr lang="en-US"/>
+            </a:p>
+          </p:txBody>
+        </p:sp>
+        <p:sp>
+          <p:nvSpPr>
+            <p:cNvPr id="24" name="Left Brace 23">
+              <a:extLst>
+                <a:ext uri="{FF2B5EF4-FFF2-40B4-BE49-F238E27FC236}">
+                  <a16:creationId xmlns:a16="http://schemas.microsoft.com/office/drawing/2014/main" id="{7B3FCEBA-076B-BCB3-371D-6D95B1746A63}"/>
+                </a:ext>
+              </a:extLst>
+            </p:cNvPr>
+            <p:cNvSpPr/>
+            <p:nvPr/>
+          </p:nvSpPr>
+          <p:spPr>
+            <a:xfrm>
+              <a:off x="5066032" y="2424224"/>
+              <a:ext cx="538608" cy="1625698"/>
+            </a:xfrm>
+            <a:prstGeom prst="leftBrace">
+              <a:avLst/>
+            </a:prstGeom>
+          </p:spPr>
+          <p:style>
+            <a:lnRef idx="2">
+              <a:schemeClr val="accent1"/>
+            </a:lnRef>
+            <a:fillRef idx="0">
+              <a:schemeClr val="accent1"/>
+            </a:fillRef>
+            <a:effectRef idx="1">
+              <a:schemeClr val="accent1"/>
+            </a:effectRef>
+            <a:fontRef idx="minor">
+              <a:schemeClr val="tx1"/>
+            </a:fontRef>
+          </p:style>
+          <p:txBody>
+            <a:bodyPr rtlCol="0" anchor="ctr"/>
+            <a:lstStyle/>
+            <a:p>
+              <a:pPr algn="ctr"/>
+              <a:endParaRPr lang="en-US"/>
+            </a:p>
+          </p:txBody>
+        </p:sp>
+        <p:pic>
+          <p:nvPicPr>
+            <p:cNvPr id="26" name="Picture 25">
+              <a:extLst>
+                <a:ext uri="{FF2B5EF4-FFF2-40B4-BE49-F238E27FC236}">
+                  <a16:creationId xmlns:a16="http://schemas.microsoft.com/office/drawing/2014/main" id="{763406FD-0E73-7795-84C0-5CE25B15547A}"/>
+                </a:ext>
+              </a:extLst>
+            </p:cNvPr>
+            <p:cNvPicPr>
+              <a:picLocks noChangeAspect="1"/>
+            </p:cNvPicPr>
+            <p:nvPr/>
+          </p:nvPicPr>
+          <p:blipFill>
+            <a:blip r:embed="rId4"/>
+            <a:stretch>
+              <a:fillRect/>
+            </a:stretch>
+          </p:blipFill>
+          <p:spPr>
+            <a:xfrm>
+              <a:off x="4709369" y="3160784"/>
+              <a:ext cx="254000" cy="152400"/>
+            </a:xfrm>
+            <a:prstGeom prst="rect">
+              <a:avLst/>
+            </a:prstGeom>
+          </p:spPr>
+        </p:pic>
+        <p:pic>
+          <p:nvPicPr>
+            <p:cNvPr id="31" name="Picture 30">
+              <a:extLst>
+                <a:ext uri="{FF2B5EF4-FFF2-40B4-BE49-F238E27FC236}">
+                  <a16:creationId xmlns:a16="http://schemas.microsoft.com/office/drawing/2014/main" id="{231EC986-EE35-18A2-8850-8CE21BE74CF5}"/>
+                </a:ext>
+              </a:extLst>
+            </p:cNvPr>
+            <p:cNvPicPr>
+              <a:picLocks noChangeAspect="1"/>
+            </p:cNvPicPr>
+            <p:nvPr/>
+          </p:nvPicPr>
+          <p:blipFill>
+            <a:blip r:embed="rId5"/>
+            <a:stretch>
+              <a:fillRect/>
+            </a:stretch>
+          </p:blipFill>
+          <p:spPr>
+            <a:xfrm>
+              <a:off x="6380224" y="1691270"/>
+              <a:ext cx="203200" cy="165100"/>
+            </a:xfrm>
+            <a:prstGeom prst="rect">
+              <a:avLst/>
+            </a:prstGeom>
+          </p:spPr>
+        </p:pic>
+        <p:pic>
+          <p:nvPicPr>
+            <p:cNvPr id="32" name="Picture 31">
+              <a:extLst>
+                <a:ext uri="{FF2B5EF4-FFF2-40B4-BE49-F238E27FC236}">
+                  <a16:creationId xmlns:a16="http://schemas.microsoft.com/office/drawing/2014/main" id="{118FADC2-DB57-9A9A-6850-49D610175A05}"/>
+                </a:ext>
+              </a:extLst>
+            </p:cNvPr>
+            <p:cNvPicPr>
+              <a:picLocks noChangeAspect="1"/>
+            </p:cNvPicPr>
+            <p:nvPr/>
+          </p:nvPicPr>
+          <p:blipFill>
+            <a:blip r:embed="rId5"/>
+            <a:stretch>
+              <a:fillRect/>
+            </a:stretch>
+          </p:blipFill>
+          <p:spPr>
+            <a:xfrm>
+              <a:off x="6370579" y="3035861"/>
+              <a:ext cx="203200" cy="165100"/>
+            </a:xfrm>
+            <a:prstGeom prst="rect">
+              <a:avLst/>
+            </a:prstGeom>
+          </p:spPr>
+        </p:pic>
+        <p:pic>
+          <p:nvPicPr>
+            <p:cNvPr id="33" name="Picture 32">
+              <a:extLst>
+                <a:ext uri="{FF2B5EF4-FFF2-40B4-BE49-F238E27FC236}">
+                  <a16:creationId xmlns:a16="http://schemas.microsoft.com/office/drawing/2014/main" id="{C7E7297D-8889-6EE7-E871-F63363EC6D33}"/>
+                </a:ext>
+              </a:extLst>
+            </p:cNvPr>
+            <p:cNvPicPr>
+              <a:picLocks noChangeAspect="1"/>
+            </p:cNvPicPr>
+            <p:nvPr/>
+          </p:nvPicPr>
+          <p:blipFill>
+            <a:blip r:embed="rId6"/>
+            <a:stretch>
+              <a:fillRect/>
+            </a:stretch>
+          </p:blipFill>
+          <p:spPr>
+            <a:xfrm>
+              <a:off x="3345405" y="1830170"/>
+              <a:ext cx="254000" cy="165100"/>
+            </a:xfrm>
+            <a:prstGeom prst="rect">
+              <a:avLst/>
+            </a:prstGeom>
+          </p:spPr>
+        </p:pic>
+        <p:pic>
+          <p:nvPicPr>
+            <p:cNvPr id="34" name="Picture 33">
+              <a:extLst>
+                <a:ext uri="{FF2B5EF4-FFF2-40B4-BE49-F238E27FC236}">
+                  <a16:creationId xmlns:a16="http://schemas.microsoft.com/office/drawing/2014/main" id="{49FE63C6-E15E-1319-45F3-BE310B3E1EA0}"/>
+                </a:ext>
+              </a:extLst>
+            </p:cNvPr>
+            <p:cNvPicPr>
+              <a:picLocks noChangeAspect="1"/>
+            </p:cNvPicPr>
+            <p:nvPr/>
+          </p:nvPicPr>
+          <p:blipFill>
+            <a:blip r:embed="rId6"/>
+            <a:stretch>
+              <a:fillRect/>
+            </a:stretch>
+          </p:blipFill>
+          <p:spPr>
+            <a:xfrm>
+              <a:off x="3347333" y="3255784"/>
+              <a:ext cx="254000" cy="165100"/>
+            </a:xfrm>
+            <a:prstGeom prst="rect">
+              <a:avLst/>
+            </a:prstGeom>
+          </p:spPr>
+        </p:pic>
+        <p:pic>
+          <p:nvPicPr>
+            <p:cNvPr id="35" name="Picture 34">
+              <a:extLst>
+                <a:ext uri="{FF2B5EF4-FFF2-40B4-BE49-F238E27FC236}">
+                  <a16:creationId xmlns:a16="http://schemas.microsoft.com/office/drawing/2014/main" id="{3B171879-A2EC-ED53-8BBB-905474110EBF}"/>
+                </a:ext>
+              </a:extLst>
+            </p:cNvPr>
+            <p:cNvPicPr>
+              <a:picLocks noChangeAspect="1"/>
+            </p:cNvPicPr>
+            <p:nvPr/>
+          </p:nvPicPr>
+          <p:blipFill>
+            <a:blip r:embed="rId7"/>
+            <a:stretch>
+              <a:fillRect/>
+            </a:stretch>
+          </p:blipFill>
+          <p:spPr>
+            <a:xfrm>
+              <a:off x="2942464" y="2538069"/>
+              <a:ext cx="596900" cy="254000"/>
+            </a:xfrm>
+            <a:prstGeom prst="rect">
+              <a:avLst/>
+            </a:prstGeom>
+          </p:spPr>
+        </p:pic>
+        <p:pic>
+          <p:nvPicPr>
+            <p:cNvPr id="36" name="Picture 35">
+              <a:extLst>
+                <a:ext uri="{FF2B5EF4-FFF2-40B4-BE49-F238E27FC236}">
+                  <a16:creationId xmlns:a16="http://schemas.microsoft.com/office/drawing/2014/main" id="{18160F0F-036C-71A0-D1B7-C9D3CF67188E}"/>
+                </a:ext>
+              </a:extLst>
+            </p:cNvPr>
+            <p:cNvPicPr>
+              <a:picLocks noChangeAspect="1"/>
+            </p:cNvPicPr>
+            <p:nvPr/>
+          </p:nvPicPr>
+          <p:blipFill>
+            <a:blip r:embed="rId8"/>
+            <a:stretch>
+              <a:fillRect/>
+            </a:stretch>
+          </p:blipFill>
+          <p:spPr>
+            <a:xfrm>
+              <a:off x="6051949" y="2271851"/>
+              <a:ext cx="558800" cy="254000"/>
+            </a:xfrm>
+            <a:prstGeom prst="rect">
+              <a:avLst/>
+            </a:prstGeom>
+          </p:spPr>
+        </p:pic>
+        <p:pic>
+          <p:nvPicPr>
+            <p:cNvPr id="37" name="Picture 36">
+              <a:extLst>
+                <a:ext uri="{FF2B5EF4-FFF2-40B4-BE49-F238E27FC236}">
+                  <a16:creationId xmlns:a16="http://schemas.microsoft.com/office/drawing/2014/main" id="{8568B358-A5E4-E587-F00C-11D09526CCFA}"/>
+                </a:ext>
+              </a:extLst>
+            </p:cNvPr>
+            <p:cNvPicPr>
+              <a:picLocks noChangeAspect="1"/>
+            </p:cNvPicPr>
+            <p:nvPr/>
+          </p:nvPicPr>
+          <p:blipFill>
+            <a:blip r:embed="rId9"/>
+            <a:stretch>
+              <a:fillRect/>
+            </a:stretch>
+          </p:blipFill>
+          <p:spPr>
+            <a:xfrm>
+              <a:off x="4508421" y="1620698"/>
+              <a:ext cx="520700" cy="190500"/>
+            </a:xfrm>
+            <a:prstGeom prst="rect">
+              <a:avLst/>
+            </a:prstGeom>
+          </p:spPr>
+        </p:pic>
+        <p:pic>
+          <p:nvPicPr>
+            <p:cNvPr id="38" name="Picture 37">
+              <a:extLst>
+                <a:ext uri="{FF2B5EF4-FFF2-40B4-BE49-F238E27FC236}">
+                  <a16:creationId xmlns:a16="http://schemas.microsoft.com/office/drawing/2014/main" id="{A4D77164-BBD8-CCA3-A559-608C443EBA95}"/>
+                </a:ext>
+              </a:extLst>
+            </p:cNvPr>
+            <p:cNvPicPr>
+              <a:picLocks noChangeAspect="1"/>
+            </p:cNvPicPr>
+            <p:nvPr/>
+          </p:nvPicPr>
+          <p:blipFill>
+            <a:blip r:embed="rId10"/>
+            <a:stretch>
+              <a:fillRect/>
+            </a:stretch>
+          </p:blipFill>
+          <p:spPr>
+            <a:xfrm>
+              <a:off x="1491527" y="1852195"/>
+              <a:ext cx="558800" cy="190500"/>
+            </a:xfrm>
+            <a:prstGeom prst="rect">
+              <a:avLst/>
+            </a:prstGeom>
+          </p:spPr>
+        </p:pic>
+        <p:pic>
+          <p:nvPicPr>
+            <p:cNvPr id="40" name="Picture 39">
+              <a:extLst>
+                <a:ext uri="{FF2B5EF4-FFF2-40B4-BE49-F238E27FC236}">
+                  <a16:creationId xmlns:a16="http://schemas.microsoft.com/office/drawing/2014/main" id="{51724FF9-FB4B-670F-F260-B9C63199DE6C}"/>
+                </a:ext>
+              </a:extLst>
+            </p:cNvPr>
+            <p:cNvPicPr>
+              <a:picLocks noChangeAspect="1"/>
+            </p:cNvPicPr>
+            <p:nvPr/>
+          </p:nvPicPr>
+          <p:blipFill>
+            <a:blip r:embed="rId11"/>
+            <a:stretch>
+              <a:fillRect/>
+            </a:stretch>
+          </p:blipFill>
+          <p:spPr>
+            <a:xfrm>
+              <a:off x="1410182" y="460978"/>
+              <a:ext cx="2133600" cy="241300"/>
+            </a:xfrm>
+            <a:prstGeom prst="rect">
+              <a:avLst/>
+            </a:prstGeom>
+          </p:spPr>
+        </p:pic>
+        <p:pic>
+          <p:nvPicPr>
+            <p:cNvPr id="41" name="Picture 40">
+              <a:extLst>
+                <a:ext uri="{FF2B5EF4-FFF2-40B4-BE49-F238E27FC236}">
+                  <a16:creationId xmlns:a16="http://schemas.microsoft.com/office/drawing/2014/main" id="{239B240F-595F-16D5-E2B1-F27BA2A3A369}"/>
+                </a:ext>
+              </a:extLst>
+            </p:cNvPr>
+            <p:cNvPicPr>
+              <a:picLocks noChangeAspect="1"/>
+            </p:cNvPicPr>
+            <p:nvPr/>
+          </p:nvPicPr>
+          <p:blipFill>
+            <a:blip r:embed="rId12"/>
+            <a:stretch>
+              <a:fillRect/>
+            </a:stretch>
+          </p:blipFill>
+          <p:spPr>
+            <a:xfrm>
+              <a:off x="4764587" y="507279"/>
+              <a:ext cx="2184400" cy="241300"/>
+            </a:xfrm>
+            <a:prstGeom prst="rect">
+              <a:avLst/>
+            </a:prstGeom>
+          </p:spPr>
+        </p:pic>
+      </p:grpSp>
+    </p:spTree>
+    <p:extLst>
+      <p:ext uri="{BB962C8B-B14F-4D97-AF65-F5344CB8AC3E}">
+        <p14:creationId xmlns:p14="http://schemas.microsoft.com/office/powerpoint/2010/main" val="3641942641"/>
       </p:ext>
     </p:extLst>
   </p:cSld>

</xml_diff>